<commit_message>
Add a Summary (key takeaways) slide to every weekly deck
Each weekly deck (PDF + PPTX) now has a 'Summary -- Key Takeaways' slide
after the code slide (and listed in the Contents), with ~5 closing
takeaways per week.

Co-Authored-By: Claude Opus 4.8 (1M context) <noreply@anthropic.com>
</commit_message>
<xml_diff>
--- a/weekly_presentations/week01_introduction.pptx
+++ b/weekly_presentations/week01_introduction.pptx
@@ -20,6 +20,7 @@
     <p:sldId id="268" r:id="rId19"/>
     <p:sldId id="269" r:id="rId20"/>
     <p:sldId id="270" r:id="rId21"/>
+    <p:sldId id="271" r:id="rId22"/>
   </p:sldIdLst>
   <p:sldSz cx="12191695" cy="6858000" type="screen4x3"/>
   <p:notesSz cx="6858000" cy="9144000"/>
@@ -4246,7 +4247,7 @@
           <a:noFill/>
         </p:spPr>
         <p:txBody>
-          <a:bodyPr wrap="none">
+          <a:bodyPr wrap="square">
             <a:spAutoFit/>
           </a:bodyPr>
           <a:lstStyle/>
@@ -4258,7 +4259,7 @@
                 </a:solidFill>
                 <a:latin typeface="Arial"/>
               </a:rPr>
-              <a:t>Glossary — Key Terms</a:t>
+              <a:t>Summary — Key Takeaways</a:t>
             </a:r>
           </a:p>
         </p:txBody>
@@ -4330,176 +4331,81 @@
           <a:p>
             <a:pPr>
               <a:spcAft>
-                <a:spcPts val="700"/>
-              </a:spcAft>
-            </a:pPr>
-            <a:r>
-              <a:rPr sz="1500" b="1" i="0">
-                <a:solidFill>
-                  <a:srgbClr val="CC0000"/>
-                </a:solidFill>
-                <a:latin typeface="Arial"/>
-              </a:rPr>
-              <a:t>Market maker — </a:t>
-            </a:r>
-            <a:r>
-              <a:rPr sz="1500" b="0" i="0">
-                <a:solidFill>
-                  <a:srgbClr val="1A1A1A"/>
-                </a:solidFill>
-                <a:latin typeface="Arial"/>
-              </a:rPr>
-              <a:t>liquidity provider that continuously quotes bid and ask, earning the spread</a:t>
-            </a:r>
-          </a:p>
-          <a:p>
-            <a:pPr>
-              <a:spcAft>
-                <a:spcPts val="700"/>
-              </a:spcAft>
-            </a:pPr>
-            <a:r>
-              <a:rPr sz="1500" b="1" i="0">
-                <a:solidFill>
-                  <a:srgbClr val="CC0000"/>
-                </a:solidFill>
-                <a:latin typeface="Arial"/>
-              </a:rPr>
-              <a:t>Taker — </a:t>
-            </a:r>
-            <a:r>
-              <a:rPr sz="1500" b="0" i="0">
-                <a:solidFill>
-                  <a:srgbClr val="1A1A1A"/>
-                </a:solidFill>
-                <a:latin typeface="Arial"/>
-              </a:rPr>
-              <a:t>participant that crosses the spread for immediate execution</a:t>
-            </a:r>
-          </a:p>
-          <a:p>
-            <a:pPr>
-              <a:spcAft>
-                <a:spcPts val="700"/>
-              </a:spcAft>
-            </a:pPr>
-            <a:r>
-              <a:rPr sz="1500" b="1" i="0">
-                <a:solidFill>
-                  <a:srgbClr val="CC0000"/>
-                </a:solidFill>
-                <a:latin typeface="Arial"/>
-              </a:rPr>
-              <a:t>Bid-ask spread — </a:t>
-            </a:r>
-            <a:r>
-              <a:rPr sz="1500" b="0" i="0">
-                <a:solidFill>
-                  <a:srgbClr val="1A1A1A"/>
-                </a:solidFill>
-                <a:latin typeface="Arial"/>
-              </a:rPr>
-              <a:t>best ask minus best bid; the maker's revenue and risk premium</a:t>
-            </a:r>
-          </a:p>
-          <a:p>
-            <a:pPr>
-              <a:spcAft>
-                <a:spcPts val="700"/>
-              </a:spcAft>
-            </a:pPr>
-            <a:r>
-              <a:rPr sz="1500" b="1" i="0">
-                <a:solidFill>
-                  <a:srgbClr val="CC0000"/>
-                </a:solidFill>
-                <a:latin typeface="Arial"/>
-              </a:rPr>
-              <a:t>Inventory — </a:t>
-            </a:r>
-            <a:r>
-              <a:rPr sz="1500" b="0" i="0">
-                <a:solidFill>
-                  <a:srgbClr val="1A1A1A"/>
-                </a:solidFill>
-                <a:latin typeface="Arial"/>
-              </a:rPr>
-              <a:t>the maker's net position; the main source of risk</a:t>
-            </a:r>
-          </a:p>
-          <a:p>
-            <a:pPr>
-              <a:spcAft>
-                <a:spcPts val="700"/>
-              </a:spcAft>
-            </a:pPr>
-            <a:r>
-              <a:rPr sz="1500" b="1" i="0">
-                <a:solidFill>
-                  <a:srgbClr val="CC0000"/>
-                </a:solidFill>
-                <a:latin typeface="Arial"/>
-              </a:rPr>
-              <a:t>Milestone — </a:t>
-            </a:r>
-            <a:r>
-              <a:rPr sz="1500" b="0" i="0">
-                <a:solidFill>
-                  <a:srgbClr val="1A1A1A"/>
-                </a:solidFill>
-                <a:latin typeface="Arial"/>
-              </a:rPr>
-              <a:t>graded software deliverable, due in Weeks 5, 7, and 9</a:t>
-            </a:r>
-          </a:p>
-          <a:p>
-            <a:pPr>
-              <a:spcAft>
-                <a:spcPts val="700"/>
-              </a:spcAft>
-            </a:pPr>
-            <a:r>
-              <a:rPr sz="1500" b="1" i="0">
-                <a:solidFill>
-                  <a:srgbClr val="CC0000"/>
-                </a:solidFill>
-                <a:latin typeface="Arial"/>
-              </a:rPr>
-              <a:t>PyTorch / autograd — </a:t>
-            </a:r>
-            <a:r>
-              <a:rPr sz="1500" b="0" i="0">
-                <a:solidFill>
-                  <a:srgbClr val="1A1A1A"/>
-                </a:solidFill>
-                <a:latin typeface="Arial"/>
-              </a:rPr>
-              <a:t>Python ML library; automatic differentiation computes Greeks for you</a:t>
-            </a:r>
-          </a:p>
-          <a:p>
-            <a:pPr>
-              <a:spcAft>
-                <a:spcPts val="700"/>
-              </a:spcAft>
-            </a:pPr>
-            <a:r>
-              <a:rPr sz="1500" b="1" i="0">
-                <a:solidFill>
-                  <a:srgbClr val="CC0000"/>
-                </a:solidFill>
-                <a:latin typeface="Arial"/>
-              </a:rPr>
-              <a:t>pybind11 — </a:t>
-            </a:r>
-            <a:r>
-              <a:rPr sz="1500" b="0" i="0">
-                <a:solidFill>
-                  <a:srgbClr val="1A1A1A"/>
-                </a:solidFill>
-                <a:latin typeface="Arial"/>
-              </a:rPr>
-              <a:t>library that exposes C++ functions to Python (used in Week 7)</a:t>
+                <a:spcPts val="800"/>
+              </a:spcAft>
+            </a:pPr>
+            <a:r>
+              <a:rPr sz="1700" b="0" i="0">
+                <a:solidFill>
+                  <a:srgbClr val="1A1A1A"/>
+                </a:solidFill>
+                <a:latin typeface="Arial"/>
+              </a:rPr>
+              <a:t>•  We build the MAKER side: continuously quote bid/ask and earn the spread</a:t>
+            </a:r>
+          </a:p>
+          <a:p>
+            <a:pPr>
+              <a:spcAft>
+                <a:spcPts val="800"/>
+              </a:spcAft>
+            </a:pPr>
+            <a:r>
+              <a:rPr sz="1700" b="0" i="0">
+                <a:solidFill>
+                  <a:srgbClr val="1A1A1A"/>
+                </a:solidFill>
+                <a:latin typeface="Arial"/>
+              </a:rPr>
+              <a:t>•  Avellaneda-Stoikov is the spine; you ship a calibrated engine by Week 5</a:t>
+            </a:r>
+          </a:p>
+          <a:p>
+            <a:pPr>
+              <a:spcAft>
+                <a:spcPts val="800"/>
+              </a:spcAft>
+            </a:pPr>
+            <a:r>
+              <a:rPr sz="1700" b="0" i="0">
+                <a:solidFill>
+                  <a:srgbClr val="1A1A1A"/>
+                </a:solidFill>
+                <a:latin typeface="Arial"/>
+              </a:rPr>
+              <a:t>•  Python/PyTorch for problem sets; C++ via pybind11 for fast computation</a:t>
+            </a:r>
+          </a:p>
+          <a:p>
+            <a:pPr>
+              <a:spcAft>
+                <a:spcPts val="800"/>
+              </a:spcAft>
+            </a:pPr>
+            <a:r>
+              <a:rPr sz="1700" b="0" i="0">
+                <a:solidFill>
+                  <a:srgbClr val="1A1A1A"/>
+                </a:solidFill>
+                <a:latin typeface="Arial"/>
+              </a:rPr>
+              <a:t>•  Three milestones (Wk 5, 7, 9); grading is 30/30/30/10</a:t>
+            </a:r>
+          </a:p>
+          <a:p>
+            <a:pPr>
+              <a:spcAft>
+                <a:spcPts val="800"/>
+              </a:spcAft>
+            </a:pPr>
+            <a:r>
+              <a:rPr sz="1700" b="0" i="0">
+                <a:solidFill>
+                  <a:srgbClr val="1A1A1A"/>
+                </a:solidFill>
+                <a:latin typeface="Arial"/>
+              </a:rPr>
+              <a:t>•  Data is Coincall (L2 only, no L3); confirm endpoints at docs.coincall.com</a:t>
             </a:r>
           </a:p>
         </p:txBody>
@@ -4563,7 +4469,7 @@
           <a:noFill/>
         </p:spPr>
         <p:txBody>
-          <a:bodyPr wrap="square">
+          <a:bodyPr wrap="none">
             <a:spAutoFit/>
           </a:bodyPr>
           <a:lstStyle/>
@@ -4575,7 +4481,7 @@
                 </a:solidFill>
                 <a:latin typeface="Arial"/>
               </a:rPr>
-              <a:t>Reading</a:t>
+              <a:t>Glossary — Key Terms</a:t>
             </a:r>
           </a:p>
         </p:txBody>
@@ -4647,33 +4553,176 @@
           <a:p>
             <a:pPr>
               <a:spcAft>
-                <a:spcPts val="800"/>
-              </a:spcAft>
-            </a:pPr>
-            <a:r>
-              <a:rPr sz="1700" b="0" i="0">
-                <a:solidFill>
-                  <a:srgbClr val="1A1A1A"/>
-                </a:solidFill>
-                <a:latin typeface="Arial"/>
-              </a:rPr>
-              <a:t>•  Cartea-Jaikumar-Penalva, Ch. 1; Avellaneda-Stoikov (2008) -- skim</a:t>
-            </a:r>
-          </a:p>
-          <a:p>
-            <a:pPr>
-              <a:spcAft>
-                <a:spcPts val="800"/>
-              </a:spcAft>
-            </a:pPr>
-            <a:r>
-              <a:rPr sz="1700" b="0" i="0">
-                <a:solidFill>
-                  <a:srgbClr val="1A1A1A"/>
-                </a:solidFill>
-                <a:latin typeface="Arial"/>
-              </a:rPr>
-              <a:t>•  Coincall API docs: https://docs.coincall.com/  (read 'Getting Started')</a:t>
+                <a:spcPts val="700"/>
+              </a:spcAft>
+            </a:pPr>
+            <a:r>
+              <a:rPr sz="1500" b="1" i="0">
+                <a:solidFill>
+                  <a:srgbClr val="CC0000"/>
+                </a:solidFill>
+                <a:latin typeface="Arial"/>
+              </a:rPr>
+              <a:t>Market maker — </a:t>
+            </a:r>
+            <a:r>
+              <a:rPr sz="1500" b="0" i="0">
+                <a:solidFill>
+                  <a:srgbClr val="1A1A1A"/>
+                </a:solidFill>
+                <a:latin typeface="Arial"/>
+              </a:rPr>
+              <a:t>liquidity provider that continuously quotes bid and ask, earning the spread</a:t>
+            </a:r>
+          </a:p>
+          <a:p>
+            <a:pPr>
+              <a:spcAft>
+                <a:spcPts val="700"/>
+              </a:spcAft>
+            </a:pPr>
+            <a:r>
+              <a:rPr sz="1500" b="1" i="0">
+                <a:solidFill>
+                  <a:srgbClr val="CC0000"/>
+                </a:solidFill>
+                <a:latin typeface="Arial"/>
+              </a:rPr>
+              <a:t>Taker — </a:t>
+            </a:r>
+            <a:r>
+              <a:rPr sz="1500" b="0" i="0">
+                <a:solidFill>
+                  <a:srgbClr val="1A1A1A"/>
+                </a:solidFill>
+                <a:latin typeface="Arial"/>
+              </a:rPr>
+              <a:t>participant that crosses the spread for immediate execution</a:t>
+            </a:r>
+          </a:p>
+          <a:p>
+            <a:pPr>
+              <a:spcAft>
+                <a:spcPts val="700"/>
+              </a:spcAft>
+            </a:pPr>
+            <a:r>
+              <a:rPr sz="1500" b="1" i="0">
+                <a:solidFill>
+                  <a:srgbClr val="CC0000"/>
+                </a:solidFill>
+                <a:latin typeface="Arial"/>
+              </a:rPr>
+              <a:t>Bid-ask spread — </a:t>
+            </a:r>
+            <a:r>
+              <a:rPr sz="1500" b="0" i="0">
+                <a:solidFill>
+                  <a:srgbClr val="1A1A1A"/>
+                </a:solidFill>
+                <a:latin typeface="Arial"/>
+              </a:rPr>
+              <a:t>best ask minus best bid; the maker's revenue and risk premium</a:t>
+            </a:r>
+          </a:p>
+          <a:p>
+            <a:pPr>
+              <a:spcAft>
+                <a:spcPts val="700"/>
+              </a:spcAft>
+            </a:pPr>
+            <a:r>
+              <a:rPr sz="1500" b="1" i="0">
+                <a:solidFill>
+                  <a:srgbClr val="CC0000"/>
+                </a:solidFill>
+                <a:latin typeface="Arial"/>
+              </a:rPr>
+              <a:t>Inventory — </a:t>
+            </a:r>
+            <a:r>
+              <a:rPr sz="1500" b="0" i="0">
+                <a:solidFill>
+                  <a:srgbClr val="1A1A1A"/>
+                </a:solidFill>
+                <a:latin typeface="Arial"/>
+              </a:rPr>
+              <a:t>the maker's net position; the main source of risk</a:t>
+            </a:r>
+          </a:p>
+          <a:p>
+            <a:pPr>
+              <a:spcAft>
+                <a:spcPts val="700"/>
+              </a:spcAft>
+            </a:pPr>
+            <a:r>
+              <a:rPr sz="1500" b="1" i="0">
+                <a:solidFill>
+                  <a:srgbClr val="CC0000"/>
+                </a:solidFill>
+                <a:latin typeface="Arial"/>
+              </a:rPr>
+              <a:t>Milestone — </a:t>
+            </a:r>
+            <a:r>
+              <a:rPr sz="1500" b="0" i="0">
+                <a:solidFill>
+                  <a:srgbClr val="1A1A1A"/>
+                </a:solidFill>
+                <a:latin typeface="Arial"/>
+              </a:rPr>
+              <a:t>graded software deliverable, due in Weeks 5, 7, and 9</a:t>
+            </a:r>
+          </a:p>
+          <a:p>
+            <a:pPr>
+              <a:spcAft>
+                <a:spcPts val="700"/>
+              </a:spcAft>
+            </a:pPr>
+            <a:r>
+              <a:rPr sz="1500" b="1" i="0">
+                <a:solidFill>
+                  <a:srgbClr val="CC0000"/>
+                </a:solidFill>
+                <a:latin typeface="Arial"/>
+              </a:rPr>
+              <a:t>PyTorch / autograd — </a:t>
+            </a:r>
+            <a:r>
+              <a:rPr sz="1500" b="0" i="0">
+                <a:solidFill>
+                  <a:srgbClr val="1A1A1A"/>
+                </a:solidFill>
+                <a:latin typeface="Arial"/>
+              </a:rPr>
+              <a:t>Python ML library; automatic differentiation computes Greeks for you</a:t>
+            </a:r>
+          </a:p>
+          <a:p>
+            <a:pPr>
+              <a:spcAft>
+                <a:spcPts val="700"/>
+              </a:spcAft>
+            </a:pPr>
+            <a:r>
+              <a:rPr sz="1500" b="1" i="0">
+                <a:solidFill>
+                  <a:srgbClr val="CC0000"/>
+                </a:solidFill>
+                <a:latin typeface="Arial"/>
+              </a:rPr>
+              <a:t>pybind11 — </a:t>
+            </a:r>
+            <a:r>
+              <a:rPr sz="1500" b="0" i="0">
+                <a:solidFill>
+                  <a:srgbClr val="1A1A1A"/>
+                </a:solidFill>
+                <a:latin typeface="Arial"/>
+              </a:rPr>
+              <a:t>library that exposes C++ functions to Python (used in Week 7)</a:t>
             </a:r>
           </a:p>
         </p:txBody>
@@ -4749,6 +4798,180 @@
                 </a:solidFill>
                 <a:latin typeface="Arial"/>
               </a:rPr>
+              <a:t>Reading</a:t>
+            </a:r>
+          </a:p>
+        </p:txBody>
+      </p:sp>
+      <p:sp>
+        <p:nvSpPr>
+          <p:cNvPr id="4" name="Rectangle 3"/>
+          <p:cNvSpPr/>
+          <p:nvPr/>
+        </p:nvSpPr>
+        <p:spPr>
+          <a:xfrm>
+            <a:off x="457200" y="1371600"/>
+            <a:ext cx="11247120" cy="27940"/>
+          </a:xfrm>
+          <a:prstGeom prst="rect">
+            <a:avLst/>
+          </a:prstGeom>
+          <a:solidFill>
+            <a:srgbClr val="CC0000"/>
+          </a:solidFill>
+          <a:ln>
+            <a:noFill/>
+          </a:ln>
+        </p:spPr>
+        <p:style>
+          <a:lnRef idx="1">
+            <a:schemeClr val="accent1"/>
+          </a:lnRef>
+          <a:fillRef idx="3">
+            <a:schemeClr val="accent1"/>
+          </a:fillRef>
+          <a:effectRef idx="2">
+            <a:schemeClr val="accent1"/>
+          </a:effectRef>
+          <a:fontRef idx="minor">
+            <a:schemeClr val="lt1"/>
+          </a:fontRef>
+        </p:style>
+        <p:txBody>
+          <a:bodyPr rtlCol="0" anchor="ctr"/>
+          <a:lstStyle/>
+          <a:p>
+            <a:pPr algn="ctr"/>
+          </a:p>
+        </p:txBody>
+      </p:sp>
+      <p:sp>
+        <p:nvSpPr>
+          <p:cNvPr id="5" name="TextBox 4"/>
+          <p:cNvSpPr txBox="1"/>
+          <p:nvPr/>
+        </p:nvSpPr>
+        <p:spPr>
+          <a:xfrm>
+            <a:off x="640080" y="1600200"/>
+            <a:ext cx="10972800" cy="4937760"/>
+          </a:xfrm>
+          <a:prstGeom prst="rect">
+            <a:avLst/>
+          </a:prstGeom>
+          <a:noFill/>
+        </p:spPr>
+        <p:txBody>
+          <a:bodyPr wrap="square">
+            <a:spAutoFit/>
+          </a:bodyPr>
+          <a:lstStyle/>
+          <a:p>
+            <a:pPr>
+              <a:spcAft>
+                <a:spcPts val="800"/>
+              </a:spcAft>
+            </a:pPr>
+            <a:r>
+              <a:rPr sz="1700" b="0" i="0">
+                <a:solidFill>
+                  <a:srgbClr val="1A1A1A"/>
+                </a:solidFill>
+                <a:latin typeface="Arial"/>
+              </a:rPr>
+              <a:t>•  Cartea-Jaikumar-Penalva, Ch. 1; Avellaneda-Stoikov (2008) -- skim</a:t>
+            </a:r>
+          </a:p>
+          <a:p>
+            <a:pPr>
+              <a:spcAft>
+                <a:spcPts val="800"/>
+              </a:spcAft>
+            </a:pPr>
+            <a:r>
+              <a:rPr sz="1700" b="0" i="0">
+                <a:solidFill>
+                  <a:srgbClr val="1A1A1A"/>
+                </a:solidFill>
+                <a:latin typeface="Arial"/>
+              </a:rPr>
+              <a:t>•  Coincall API docs: https://docs.coincall.com/  (read 'Getting Started')</a:t>
+            </a:r>
+          </a:p>
+        </p:txBody>
+      </p:sp>
+    </p:spTree>
+  </p:cSld>
+  <p:clrMapOvr>
+    <a:masterClrMapping/>
+  </p:clrMapOvr>
+</p:sld>
+</file>
+
+<file path=ppt/slides/slide16.xml><?xml version="1.0" encoding="utf-8"?>
+<p:sld xmlns:a="http://schemas.openxmlformats.org/drawingml/2006/main" xmlns:p="http://schemas.openxmlformats.org/presentationml/2006/main" xmlns:r="http://schemas.openxmlformats.org/officeDocument/2006/relationships">
+  <p:cSld>
+    <p:spTree>
+      <p:nvGrpSpPr>
+        <p:cNvPr id="1" name=""/>
+        <p:cNvGrpSpPr/>
+        <p:nvPr/>
+      </p:nvGrpSpPr>
+      <p:grpSpPr/>
+      <p:pic>
+        <p:nvPicPr>
+          <p:cNvPr id="2" name="Picture 1" descr="ncsu_logo.png"/>
+          <p:cNvPicPr>
+            <a:picLocks noChangeAspect="1"/>
+          </p:cNvPicPr>
+          <p:nvPr/>
+        </p:nvPicPr>
+        <p:blipFill>
+          <a:blip r:embed="rId2"/>
+          <a:stretch>
+            <a:fillRect/>
+          </a:stretch>
+        </p:blipFill>
+        <p:spPr>
+          <a:xfrm>
+            <a:off x="9784080" y="274320"/>
+            <a:ext cx="2011680" cy="316653"/>
+          </a:xfrm>
+          <a:prstGeom prst="rect">
+            <a:avLst/>
+          </a:prstGeom>
+        </p:spPr>
+      </p:pic>
+      <p:sp>
+        <p:nvSpPr>
+          <p:cNvPr id="3" name="TextBox 2"/>
+          <p:cNvSpPr txBox="1"/>
+          <p:nvPr/>
+        </p:nvSpPr>
+        <p:spPr>
+          <a:xfrm>
+            <a:off x="457200" y="457200"/>
+            <a:ext cx="8961120" cy="822960"/>
+          </a:xfrm>
+          <a:prstGeom prst="rect">
+            <a:avLst/>
+          </a:prstGeom>
+          <a:noFill/>
+        </p:spPr>
+        <p:txBody>
+          <a:bodyPr wrap="square">
+            <a:spAutoFit/>
+          </a:bodyPr>
+          <a:lstStyle/>
+          <a:p>
+            <a:r>
+              <a:rPr sz="2400" b="1" i="0">
+                <a:solidFill>
+                  <a:srgbClr val="990000"/>
+                </a:solidFill>
+                <a:latin typeface="Arial"/>
+              </a:rPr>
               <a:t>References</a:t>
             </a:r>
           </a:p>
@@ -5182,6 +5405,22 @@
                 <a:latin typeface="Arial"/>
               </a:rPr>
               <a:t>•  Code: coincall_client.py</a:t>
+            </a:r>
+          </a:p>
+          <a:p>
+            <a:pPr>
+              <a:spcAft>
+                <a:spcPts val="500"/>
+              </a:spcAft>
+            </a:pPr>
+            <a:r>
+              <a:rPr sz="1200" b="0" i="0">
+                <a:solidFill>
+                  <a:srgbClr val="1A1A1A"/>
+                </a:solidFill>
+                <a:latin typeface="Arial"/>
+              </a:rPr>
+              <a:t>•  Summary &amp; key takeaways</a:t>
             </a:r>
           </a:p>
           <a:p>

</xml_diff>